<commit_message>
Update career presentation title to reflect focus on AI consumption in software-hardware engineering
</commit_message>
<xml_diff>
--- a/career-slides.pptx
+++ b/career-slides.pptx
@@ -3144,7 +3144,7 @@
             </a:pPr>
             <a:r>
               <a:rPr/>
-              <a:t>AI</a:t>
+              <a:t>Ai</a:t>
             </a:r>
             <a:r>
               <a:rPr/>
@@ -3152,7 +3152,7 @@
             </a:r>
             <a:r>
               <a:rPr/>
-              <a:t>and</a:t>
+              <a:t>consumption</a:t>
             </a:r>
             <a:r>
               <a:rPr/>
@@ -3160,7 +3160,7 @@
             </a:r>
             <a:r>
               <a:rPr/>
-              <a:t>My</a:t>
+              <a:t>in</a:t>
             </a:r>
             <a:r>
               <a:rPr/>
@@ -3168,7 +3168,7 @@
             </a:r>
             <a:r>
               <a:rPr/>
-              <a:t>Future</a:t>
+              <a:t>Software-hardware</a:t>
             </a:r>
             <a:r>
               <a:rPr/>
@@ -3176,7 +3176,7 @@
             </a:r>
             <a:r>
               <a:rPr/>
-              <a:t>Career</a:t>
+              <a:t>engineering</a:t>
             </a:r>
           </a:p>
         </p:txBody>

</xml_diff>

<commit_message>
Update career presentation title to emphasize AI integration in software-hardware engineering
</commit_message>
<xml_diff>
--- a/career-slides.pptx
+++ b/career-slides.pptx
@@ -3321,7 +3321,7 @@
             </a:r>
             <a:r>
               <a:rPr/>
-              <a:t>Software</a:t>
+              <a:t>Electrical</a:t>
             </a:r>
             <a:r>
               <a:rPr/>
@@ -3337,7 +3337,7 @@
             </a:r>
             <a:r>
               <a:rPr/>
-              <a:t>electrical</a:t>
+              <a:t>computer</a:t>
             </a:r>
             <a:r>
               <a:rPr/>
@@ -3455,7 +3455,7 @@
             </a:r>
             <a:r>
               <a:rPr/>
-              <a:t> the machine: drivers, RTOS tasks, bootloaders</a:t>
+              <a:t> the machine: design systems where code directly interacts with physical components Ex. Infrared scanner</a:t>
             </a:r>
           </a:p>
           <a:p>
@@ -3470,7 +3470,7 @@
             </a:r>
             <a:r>
               <a:rPr/>
-              <a:t> on bring-up, timing, power, and reliability</a:t>
+              <a:t> on bring-up, timing, power, and reliability testing</a:t>
             </a:r>
           </a:p>
           <a:p>
@@ -3481,11 +3481,11 @@
             </a:r>
             <a:r>
               <a:rPr b="1"/>
-              <a:t>C/Rust</a:t>
-            </a:r>
-            <a:r>
-              <a:rPr/>
-              <a:t>, digital fundamentals, measurement, clear docs</a:t>
+              <a:t>programming</a:t>
+            </a:r>
+            <a:r>
+              <a:rPr/>
+              <a:t>, lab fundamentals, doc writing, collaboration</a:t>
             </a:r>
           </a:p>
         </p:txBody>
@@ -3599,7 +3599,7 @@
             </a:r>
             <a:r>
               <a:rPr b="1"/>
-              <a:t>closed loops</a:t>
+              <a:t>innovation</a:t>
             </a:r>
             <a:r>
               <a:rPr/>
@@ -3614,26 +3614,18 @@
             </a:r>
             <a:r>
               <a:rPr b="1"/>
-              <a:t>math, physics, and programming</a:t>
-            </a:r>
-            <a:r>
-              <a:rPr/>
-              <a:t> without staying purely abstract</a:t>
+              <a:t>problem solving and creativity</a:t>
             </a:r>
           </a:p>
           <a:p>
             <a:pPr lvl="1"/>
             <a:r>
               <a:rPr/>
-              <a:t>Problems are tangible—</a:t>
+              <a:t>Problems are limitless—</a:t>
             </a:r>
             <a:r>
               <a:rPr b="1"/>
-              <a:t>oscilloscopes, logs, and latencies</a:t>
-            </a:r>
-            <a:r>
-              <a:rPr/>
-              <a:t> keep you honest</a:t>
+              <a:t>so are solutions</a:t>
             </a:r>
           </a:p>
         </p:txBody>
@@ -3739,29 +3731,29 @@
             </a:r>
             <a:r>
               <a:rPr/>
-              <a:t> from models and copilots—review becomes the bottleneck</a:t>
+              <a:t> automates low-level and some complex coding tasks</a:t>
             </a:r>
           </a:p>
           <a:p>
             <a:pPr lvl="1"/>
             <a:r>
               <a:rPr b="1"/>
-              <a:t>Datasheet Q&amp;A</a:t>
-            </a:r>
-            <a:r>
-              <a:rPr/>
-              <a:t> compressed; risk of confident wrong register advice</a:t>
+              <a:t>Shifts skill demand upward:</a:t>
+            </a:r>
+            <a:r>
+              <a:rPr/>
+              <a:t> system architecture, integration, and optimization rather than code from scratch</a:t>
             </a:r>
           </a:p>
           <a:p>
             <a:pPr lvl="1"/>
             <a:r>
               <a:rPr b="1"/>
-              <a:t>Layout &amp; constraint assist</a:t>
-            </a:r>
-            <a:r>
-              <a:rPr/>
-              <a:t> shifts how juniors learn PCB craft</a:t>
+              <a:t>More advanced systems-Ai driven</a:t>
+            </a:r>
+            <a:r>
+              <a:rPr/>
+              <a:t> shifts standard of basic skills</a:t>
             </a:r>
           </a:p>
           <a:p>

</xml_diff>